<commit_message>
Update DOCX and PPTX docs with correct credentials and role names
- IMGC_PAS_Application_Guide.docx: Fix login credentials table
  (emails @pas.com → @imgc.com, password123 → demo123), update role
  names (Agent → Operations, Auditor → Viewer) across credentials
  and RBAC permissions tables
- IMGC_PAS_Client_Demo.pptx: Fix role names on Slide 2 (auth) and
  Slide 14 (admin) from Agent/Auditor to Operations/Viewer

Co-Authored-By: Claude Opus 4.6 <noreply@anthropic.com>
</commit_message>
<xml_diff>
--- a/IMGC_PAS_Client_Demo.pptx
+++ b/IMGC_PAS_Client_Demo.pptx
@@ -6966,26 +6966,26 @@
               </a:defRPr>
             </a:pPr>
             <a:r>
-              <a:t>  — Agent: Customer-facing operations</a:t>
-            </a:r>
-          </a:p>
-          <a:p>
-            <a:pPr>
-              <a:spcBef>
-                <a:spcPts val="300"/>
-              </a:spcBef>
-              <a:spcAft>
-                <a:spcPts val="300"/>
-              </a:spcAft>
-              <a:defRPr sz="1200">
-                <a:solidFill>
-                  <a:srgbClr val="1E293B"/>
-                </a:solidFill>
-                <a:latin typeface="Calibri"/>
-              </a:defRPr>
-            </a:pPr>
-            <a:r>
-              <a:t>  — Auditor: Read-only compliance</a:t>
+              <a:t>  — Operations: Customer-facing operations</a:t>
+            </a:r>
+          </a:p>
+          <a:p>
+            <a:pPr>
+              <a:spcBef>
+                <a:spcPts val="300"/>
+              </a:spcBef>
+              <a:spcAft>
+                <a:spcPts val="300"/>
+              </a:spcAft>
+              <a:defRPr sz="1200">
+                <a:solidFill>
+                  <a:srgbClr val="1E293B"/>
+                </a:solidFill>
+                <a:latin typeface="Calibri"/>
+              </a:defRPr>
+            </a:pPr>
+            <a:r>
+              <a:t>  — Viewer: Read-only compliance</a:t>
             </a:r>
           </a:p>
           <a:p>
@@ -13282,26 +13282,26 @@
               </a:defRPr>
             </a:pPr>
             <a:r>
-              <a:t>• Agent — Customer-facing operations</a:t>
-            </a:r>
-          </a:p>
-          <a:p>
-            <a:pPr>
-              <a:spcBef>
-                <a:spcPts val="300"/>
-              </a:spcBef>
-              <a:spcAft>
-                <a:spcPts val="300"/>
-              </a:spcAft>
-              <a:defRPr sz="1200">
-                <a:solidFill>
-                  <a:srgbClr val="1E293B"/>
-                </a:solidFill>
-                <a:latin typeface="Calibri"/>
-              </a:defRPr>
-            </a:pPr>
-            <a:r>
-              <a:t>• Auditor — Read-only compliance review</a:t>
+              <a:t>• Operations — Customer-facing operations</a:t>
+            </a:r>
+          </a:p>
+          <a:p>
+            <a:pPr>
+              <a:spcBef>
+                <a:spcPts val="300"/>
+              </a:spcBef>
+              <a:spcAft>
+                <a:spcPts val="300"/>
+              </a:spcAft>
+              <a:defRPr sz="1200">
+                <a:solidFill>
+                  <a:srgbClr val="1E293B"/>
+                </a:solidFill>
+                <a:latin typeface="Calibri"/>
+              </a:defRPr>
+            </a:pPr>
+            <a:r>
+              <a:t>• Viewer — Read-only compliance review</a:t>
             </a:r>
           </a:p>
         </p:txBody>

</xml_diff>